<commit_message>
Add Jan 2025 seminar materials and update README
</commit_message>
<xml_diff>
--- a/Algorithm of Thoughts_변윤성_11.24.pptx
+++ b/Algorithm of Thoughts_변윤성_11.24.pptx
@@ -239,7 +239,7 @@
           <a:p>
             <a:fld id="{77A3B795-2DD5-41AD-8751-5C4089DF444F}" type="datetimeFigureOut">
               <a:rPr lang="ko-KR" altLang="en-US" smtClean="0"/>
-              <a:t>2025-11-24</a:t>
+              <a:t>2026-01-03</a:t>
             </a:fld>
             <a:endParaRPr lang="ko-KR" altLang="en-US"/>
           </a:p>
@@ -685,7 +685,7 @@
           <a:p>
             <a:fld id="{433D2B1C-BF43-4DE7-ABE0-B047D62A78C0}" type="datetime1">
               <a:rPr lang="en-US" altLang="ko-KR" smtClean="0"/>
-              <a:t>11/24/2025</a:t>
+              <a:t>1/3/2026</a:t>
             </a:fld>
             <a:endParaRPr lang="en-US"/>
           </a:p>
@@ -849,7 +849,7 @@
           <a:p>
             <a:fld id="{1222E487-4CBF-4938-A927-D22297E05349}" type="datetime1">
               <a:rPr lang="en-US" altLang="ko-KR" smtClean="0"/>
-              <a:t>11/24/2025</a:t>
+              <a:t>1/3/2026</a:t>
             </a:fld>
             <a:endParaRPr lang="en-US"/>
           </a:p>
@@ -1023,7 +1023,7 @@
           <a:p>
             <a:fld id="{979F8D2E-2F69-417D-9B17-4140C005495E}" type="datetime1">
               <a:rPr lang="en-US" altLang="ko-KR" smtClean="0"/>
-              <a:t>11/24/2025</a:t>
+              <a:t>1/3/2026</a:t>
             </a:fld>
             <a:endParaRPr lang="en-US"/>
           </a:p>
@@ -1187,7 +1187,7 @@
           <a:p>
             <a:fld id="{FD56A5C2-0AC0-4C27-B972-27F3E6623A31}" type="datetime1">
               <a:rPr lang="en-US" altLang="ko-KR" smtClean="0"/>
-              <a:t>11/24/2025</a:t>
+              <a:t>1/3/2026</a:t>
             </a:fld>
             <a:endParaRPr lang="en-US"/>
           </a:p>
@@ -1428,7 +1428,7 @@
           <a:p>
             <a:fld id="{ACCC3253-B364-4353-8945-5F93EC62AEA8}" type="datetime1">
               <a:rPr lang="en-US" altLang="ko-KR" smtClean="0"/>
-              <a:t>11/24/2025</a:t>
+              <a:t>1/3/2026</a:t>
             </a:fld>
             <a:endParaRPr lang="en-US"/>
           </a:p>
@@ -1709,7 +1709,7 @@
           <a:p>
             <a:fld id="{AB28D38A-FBC9-4474-860E-0943576FB2A9}" type="datetime1">
               <a:rPr lang="en-US" altLang="ko-KR" smtClean="0"/>
-              <a:t>11/24/2025</a:t>
+              <a:t>1/3/2026</a:t>
             </a:fld>
             <a:endParaRPr lang="en-US"/>
           </a:p>
@@ -2124,7 +2124,7 @@
           <a:p>
             <a:fld id="{DCE8A005-A359-4551-8385-DF962D05B961}" type="datetime1">
               <a:rPr lang="en-US" altLang="ko-KR" smtClean="0"/>
-              <a:t>11/24/2025</a:t>
+              <a:t>1/3/2026</a:t>
             </a:fld>
             <a:endParaRPr lang="en-US"/>
           </a:p>
@@ -2237,7 +2237,7 @@
           <a:p>
             <a:fld id="{23987605-D5BC-4F76-AD54-FBE4D0EF73CC}" type="datetime1">
               <a:rPr lang="en-US" altLang="ko-KR" smtClean="0"/>
-              <a:t>11/24/2025</a:t>
+              <a:t>1/3/2026</a:t>
             </a:fld>
             <a:endParaRPr lang="en-US"/>
           </a:p>
@@ -2328,7 +2328,7 @@
           <a:p>
             <a:fld id="{F79D134F-D1A4-4FC3-B616-E1519CFBDFE8}" type="datetime1">
               <a:rPr lang="en-US" altLang="ko-KR" smtClean="0"/>
-              <a:t>11/24/2025</a:t>
+              <a:t>1/3/2026</a:t>
             </a:fld>
             <a:endParaRPr lang="en-US"/>
           </a:p>
@@ -2599,7 +2599,7 @@
           <a:p>
             <a:fld id="{43006EF1-72F3-46B4-913E-2E8BF85C7B09}" type="datetime1">
               <a:rPr lang="en-US" altLang="ko-KR" smtClean="0"/>
-              <a:t>11/24/2025</a:t>
+              <a:t>1/3/2026</a:t>
             </a:fld>
             <a:endParaRPr lang="en-US"/>
           </a:p>
@@ -2847,7 +2847,7 @@
           <a:p>
             <a:fld id="{C0B54CDE-32A1-474B-A1A7-B2AE31A053DC}" type="datetime1">
               <a:rPr lang="en-US" altLang="ko-KR" smtClean="0"/>
-              <a:t>11/24/2025</a:t>
+              <a:t>1/3/2026</a:t>
             </a:fld>
             <a:endParaRPr lang="en-US"/>
           </a:p>
@@ -3054,7 +3054,7 @@
           <a:p>
             <a:fld id="{CDD90963-C5EF-42F4-8651-C8B07638FE5F}" type="datetime1">
               <a:rPr lang="en-US" altLang="ko-KR" smtClean="0"/>
-              <a:t>11/24/2025</a:t>
+              <a:t>1/3/2026</a:t>
             </a:fld>
             <a:endParaRPr lang="en-US"/>
           </a:p>
@@ -3593,7 +3593,7 @@
             </a:pPr>
             <a:r>
               <a:rPr lang="en-US" altLang="ko-KR" sz="4800" dirty="0"/>
-              <a:t>Algorithm of Thoughts:</a:t>
+              <a:t>Algorithm of Thoughts: </a:t>
             </a:r>
           </a:p>
           <a:p>
@@ -3648,7 +3648,7 @@
               </a:spcBef>
             </a:pPr>
             <a:r>
-              <a:rPr lang="en-US" sz="2599" u="none" strike="noStrike" dirty="0">
+              <a:rPr lang="en-US" sz="2599" u="none" strike="noStrike">
                 <a:solidFill>
                   <a:srgbClr val="191919"/>
                 </a:solidFill>
@@ -3659,6 +3659,15 @@
               </a:rPr>
               <a:t>2025.11.24</a:t>
             </a:r>
+            <a:endParaRPr lang="en-US" sz="2599" u="none" strike="noStrike" dirty="0">
+              <a:solidFill>
+                <a:srgbClr val="191919"/>
+              </a:solidFill>
+              <a:latin typeface="Garet Light"/>
+              <a:ea typeface="Garet Light"/>
+              <a:cs typeface="Garet Light"/>
+              <a:sym typeface="Garet Light"/>
+            </a:endParaRPr>
           </a:p>
         </p:txBody>
       </p:sp>

</xml_diff>